<commit_message>
feat: add presenter notes to all 8 PPT slides and sync speaker script
- Each slide now has speaker notes visible in presenter view
- Notes include timing cues, speaking lines, operations, and fallbacks
- Tone: techy, accessible, witty
- Speaker script document restructured to match PPT page-by-page
</commit_message>
<xml_diff>
--- a/output/presentation/星星之火_SkillForge_三分钟路演_v2.pptx
+++ b/output/presentation/星星之火_SkillForge_三分钟路演_v2.pptx
@@ -544,27 +544,31 @@
           <a:lstStyle xmlns:a="http://schemas.openxmlformats.org/drawingml/2006/main"/>
           <a:p xmlns:a="http://schemas.openxmlformats.org/drawingml/2006/main">
             <a:r>
-              <a:t>大家好，我们是星星之火，参加 NVIDIA DGX SPARK 黑客松 2026。</a:t>
-            </a:r>
-          </a:p>
-          <a:p xmlns:a="http://schemas.openxmlformats.org/drawingml/2006/main">
-            <a:r>
-              <a:t/>
-            </a:r>
-          </a:p>
-          <a:p xmlns:a="http://schemas.openxmlformats.org/drawingml/2006/main">
-            <a:r>
-              <a:t>我们想解决的不是“如何再生成一份教程”，而是如何让关键操作经验真正留在组织里。专家离开、人员换班或设备升级后，如果步骤没有证据、无法验证，也无法在发现问题后修订，培训就会失真。</a:t>
-            </a:r>
-          </a:p>
-          <a:p xmlns:a="http://schemas.openxmlformats.org/drawingml/2006/main">
-            <a:r>
-              <a:t/>
-            </a:r>
-          </a:p>
-          <a:p xmlns:a="http://schemas.openxmlformats.org/drawingml/2006/main">
-            <a:r>
-              <a:t>SkillForge 把专家操作视频、设备手册和口述经验，转成可执行、可追溯、可验证、会自我修订的培训能力：每一步能回源，每个问题可复检，每次修改可审计。</a:t>
+              <a:t>【第1段 · 开场 · 0-20秒 · 本页停留约10秒】</a:t>
+            </a:r>
+          </a:p>
+          <a:p xmlns:a="http://schemas.openxmlformats.org/drawingml/2006/main"/>
+          <a:p xmlns:a="http://schemas.openxmlformats.org/drawingml/2006/main">
+            <a:r>
+              <a:t>大家好，我们是星星之火。今天带来的作品叫 SkillForge——匠传。</a:t>
+            </a:r>
+          </a:p>
+          <a:p xmlns:a="http://schemas.openxmlformats.org/drawingml/2006/main"/>
+          <a:p xmlns:a="http://schemas.openxmlformats.org/drawingml/2006/main">
+            <a:r>
+              <a:t>我们想解决一个问题：关键操作经验散落在视频、手册和老师傅口述里，人员一流动，知识就失真。SkillForge 要做的，是让专家经验变成可追溯、可验证、会自我修订的培训能力。</a:t>
+            </a:r>
+          </a:p>
+          <a:p xmlns:a="http://schemas.openxmlformats.org/drawingml/2006/main"/>
+          <a:p xmlns:a="http://schemas.openxmlformats.org/drawingml/2006/main">
+            <a:r>
+              <a:t>以汉印 N31 换纸为例——看似简单，新手却很容易漏掉导纸夹、介质学习和试印验收，而普通内容生成无法证明每句话从哪里来。</a:t>
+            </a:r>
+          </a:p>
+          <a:p xmlns:a="http://schemas.openxmlformats.org/drawingml/2006/main"/>
+          <a:p xmlns:a="http://schemas.openxmlformats.org/drawingml/2006/main">
+            <a:r>
+              <a:t>【操作】展示封面，然后切到第2页。不操作网页。</a:t>
             </a:r>
           </a:p>
         </p:txBody>
@@ -632,7 +636,45 @@
         <p:txBody>
           <a:bodyPr xmlns:a="http://schemas.openxmlformats.org/drawingml/2006/main"/>
           <a:lstStyle xmlns:a="http://schemas.openxmlformats.org/drawingml/2006/main"/>
+          <a:p xmlns:a="http://schemas.openxmlformats.org/drawingml/2006/main">
+            <a:r>
+              <a:t>【第1段续 + 第2段 · 20-40秒 · 本页停留约15秒】</a:t>
+            </a:r>
+          </a:p>
           <a:p xmlns:a="http://schemas.openxmlformats.org/drawingml/2006/main"/>
+          <a:p xmlns:a="http://schemas.openxmlformats.org/drawingml/2006/main">
+            <a:r>
+              <a:t>（指向左侧"最容易漏掉的不是大动作"）</a:t>
+            </a:r>
+          </a:p>
+          <a:p xmlns:a="http://schemas.openxmlformats.org/drawingml/2006/main">
+            <a:r>
+              <a:t>导纸夹宽度与居中、缝标介质学习、试印与完成验收——这三步，老师傅觉得"不用说"，新手觉得"不用学"，直到打印出来全是歪的。</a:t>
+            </a:r>
+          </a:p>
+          <a:p xmlns:a="http://schemas.openxmlformats.org/drawingml/2006/main"/>
+          <a:p xmlns:a="http://schemas.openxmlformats.org/drawingml/2006/main">
+            <a:r>
+              <a:t>（指向右侧三类输入）</a:t>
+            </a:r>
+          </a:p>
+          <a:p xmlns:a="http://schemas.openxmlformats.org/drawingml/2006/main">
+            <a:r>
+              <a:t>SkillForge 接收三种原料：专家操作视频，绑定时间点；设备 PDF 手册，绑定页码；专家口述录音，绑定时间段。原始敏感素材留在本地，公开演示只用安全派生物。</a:t>
+            </a:r>
+          </a:p>
+          <a:p xmlns:a="http://schemas.openxmlformats.org/drawingml/2006/main"/>
+          <a:p xmlns:a="http://schemas.openxmlformats.org/drawingml/2006/main">
+            <a:r>
+              <a:t>6段自摄视频、2份手册、12段口述，汇成154条 Evidence Catalog——每句话都有出处。</a:t>
+            </a:r>
+          </a:p>
+          <a:p xmlns:a="http://schemas.openxmlformats.org/drawingml/2006/main"/>
+          <a:p xmlns:a="http://schemas.openxmlformats.org/drawingml/2006/main">
+            <a:r>
+              <a:t>【操作】展示三类输入区域，然后切到第3页。</a:t>
+            </a:r>
+          </a:p>
         </p:txBody>
       </p:sp>
       <p:sp>
@@ -698,7 +740,29 @@
         <p:txBody>
           <a:bodyPr xmlns:a="http://schemas.openxmlformats.org/drawingml/2006/main"/>
           <a:lstStyle xmlns:a="http://schemas.openxmlformats.org/drawingml/2006/main"/>
+          <a:p xmlns:a="http://schemas.openxmlformats.org/drawingml/2006/main">
+            <a:r>
+              <a:t>【第2段续 · 本页停留约5秒，快速过渡】</a:t>
+            </a:r>
+          </a:p>
           <a:p xmlns:a="http://schemas.openxmlformats.org/drawingml/2006/main"/>
+          <a:p xmlns:a="http://schemas.openxmlformats.org/drawingml/2006/main">
+            <a:r>
+              <a:t>五个 Agent，各司其职：Perception 提取证据，SOP 规划步骤，Creator 生成内容，Verifier 质检找茬，Revision 只改出错的地方。</a:t>
+            </a:r>
+          </a:p>
+          <a:p xmlns:a="http://schemas.openxmlformats.org/drawingml/2006/main"/>
+          <a:p xmlns:a="http://schemas.openxmlformats.org/drawingml/2006/main">
+            <a:r>
+              <a:t>注意这个闭环——Verifier 发现问题不是推倒重来，而是精准外科手术：哪里错了改哪里，其余不动。</a:t>
+            </a:r>
+          </a:p>
+          <a:p xmlns:a="http://schemas.openxmlformats.org/drawingml/2006/main"/>
+          <a:p xmlns:a="http://schemas.openxmlformats.org/drawingml/2006/main">
+            <a:r>
+              <a:t>【操作】快速展示后切到浏览器（Web）。Alt+Tab 切换。</a:t>
+            </a:r>
+          </a:p>
         </p:txBody>
       </p:sp>
       <p:sp>
@@ -764,7 +828,35 @@
         <p:txBody>
           <a:bodyPr xmlns:a="http://schemas.openxmlformats.org/drawingml/2006/main"/>
           <a:lstStyle xmlns:a="http://schemas.openxmlformats.org/drawingml/2006/main"/>
+          <a:p xmlns:a="http://schemas.openxmlformats.org/drawingml/2006/main">
+            <a:r>
+              <a:t>【第4段兜底 · 70-110秒 · 仅当Web不可用时展示本页】</a:t>
+            </a:r>
+          </a:p>
           <a:p xmlns:a="http://schemas.openxmlformats.org/drawingml/2006/main"/>
+          <a:p xmlns:a="http://schemas.openxmlformats.org/drawingml/2006/main">
+            <a:r>
+              <a:t>如果 Web 演示挂了，用这页兜底：</a:t>
+            </a:r>
+          </a:p>
+          <a:p xmlns:a="http://schemas.openxmlformats.org/drawingml/2006/main"/>
+          <a:p xmlns:a="http://schemas.openxmlformats.org/drawingml/2006/main">
+            <a:r>
+              <a:t>Verifier 在 Gold 受控错误集上发现5个严重问题：缺步骤、顺序错误、无依据工具、无依据参数。它引用视频 E039、手册 E104 P20、口述 E148 等多源证据，执行4处局部修订，复检后严重错误归零。</a:t>
+            </a:r>
+          </a:p>
+          <a:p xmlns:a="http://schemas.openxmlformats.org/drawingml/2006/main"/>
+          <a:p xmlns:a="http://schemas.openxmlformats.org/drawingml/2006/main">
+            <a:r>
+              <a:t>关键数字：5→0，4处修改，不整包重写。</a:t>
+            </a:r>
+          </a:p>
+          <a:p xmlns:a="http://schemas.openxmlformats.org/drawingml/2006/main"/>
+          <a:p xmlns:a="http://schemas.openxmlformats.org/drawingml/2006/main">
+            <a:r>
+              <a:t>（正常情况下这页不展示，直接在 Web 上操作。）</a:t>
+            </a:r>
+          </a:p>
         </p:txBody>
       </p:sp>
       <p:sp>
@@ -830,7 +922,29 @@
         <p:txBody>
           <a:bodyPr xmlns:a="http://schemas.openxmlformats.org/drawingml/2006/main"/>
           <a:lstStyle xmlns:a="http://schemas.openxmlformats.org/drawingml/2006/main"/>
+          <a:p xmlns:a="http://schemas.openxmlformats.org/drawingml/2006/main">
+            <a:r>
+              <a:t>【第3-4段辅助 · 可选展示】</a:t>
+            </a:r>
+          </a:p>
           <a:p xmlns:a="http://schemas.openxmlformats.org/drawingml/2006/main"/>
+          <a:p xmlns:a="http://schemas.openxmlformats.org/drawingml/2006/main">
+            <a:r>
+              <a:t>以 S09 缝标学习为例：一条步骤同时引用 PDF 第20页、视频 190-195秒、口述 153-195秒。</a:t>
+            </a:r>
+          </a:p>
+          <a:p xmlns:a="http://schemas.openxmlformats.org/drawingml/2006/main"/>
+          <a:p xmlns:a="http://schemas.openxmlformats.org/drawingml/2006/main">
+            <a:r>
+              <a:t>引用存在不等于证据充分——低可见度、遮挡和来源冲突会进入待复核，不会被伪装成事实。这是 SkillForge 和"AI 生成教程"的本质区别：我们不只给引用，还给置信度边界。</a:t>
+            </a:r>
+          </a:p>
+          <a:p xmlns:a="http://schemas.openxmlformats.org/drawingml/2006/main"/>
+          <a:p xmlns:a="http://schemas.openxmlformats.org/drawingml/2006/main">
+            <a:r>
+              <a:t>（正常流程中这页不单独展示，Web 上直接点 Evidence ID 看。）</a:t>
+            </a:r>
+          </a:p>
         </p:txBody>
       </p:sp>
       <p:sp>
@@ -896,7 +1010,35 @@
         <p:txBody>
           <a:bodyPr xmlns:a="http://schemas.openxmlformats.org/drawingml/2006/main"/>
           <a:lstStyle xmlns:a="http://schemas.openxmlformats.org/drawingml/2006/main"/>
+          <a:p xmlns:a="http://schemas.openxmlformats.org/drawingml/2006/main">
+            <a:r>
+              <a:t>【第3段兜底 · 40-70秒 · 仅当Web不可用时展示本页】</a:t>
+            </a:r>
+          </a:p>
           <a:p xmlns:a="http://schemas.openxmlformats.org/drawingml/2006/main"/>
+          <a:p xmlns:a="http://schemas.openxmlformats.org/drawingml/2006/main">
+            <a:r>
+              <a:t>如果 Web 没起来，用这页讲 DGX：</a:t>
+            </a:r>
+          </a:p>
+          <a:p xmlns:a="http://schemas.openxmlformats.org/drawingml/2006/main"/>
+          <a:p xmlns:a="http://schemas.openxmlformats.org/drawingml/2006/main">
+            <a:r>
+              <a:t>NVIDIA GB10 上跑原生 CUDA，6段安全视频、420帧处理、50个候选帧，端到端13秒。</a:t>
+            </a:r>
+          </a:p>
+          <a:p xmlns:a="http://schemas.openxmlformats.org/drawingml/2006/main"/>
+          <a:p xmlns:a="http://schemas.openxmlformats.org/drawingml/2006/main">
+            <a:r>
+              <a:t>重点：候选筛选不等于语义结论。GPU 负责"哪些帧值得看"，Agent 负责"看到了什么"。P0 全程不需要 Docker，原生 Python 加 FFmpeg 就能跑。</a:t>
+            </a:r>
+          </a:p>
+          <a:p xmlns:a="http://schemas.openxmlformats.org/drawingml/2006/main"/>
+          <a:p xmlns:a="http://schemas.openxmlformats.org/drawingml/2006/main">
+            <a:r>
+              <a:t>（正常情况下这页不展示，直接在 Web 上指向 DGX 区域。）</a:t>
+            </a:r>
+          </a:p>
         </p:txBody>
       </p:sp>
       <p:sp>
@@ -962,7 +1104,47 @@
         <p:txBody>
           <a:bodyPr xmlns:a="http://schemas.openxmlformats.org/drawingml/2006/main"/>
           <a:lstStyle xmlns:a="http://schemas.openxmlformats.org/drawingml/2006/main"/>
+          <a:p xmlns:a="http://schemas.openxmlformats.org/drawingml/2006/main">
+            <a:r>
+              <a:t>【第6段 · 140-160秒 · 本页停留约20秒】</a:t>
+            </a:r>
+          </a:p>
           <a:p xmlns:a="http://schemas.openxmlformats.org/drawingml/2006/main"/>
+          <a:p xmlns:a="http://schemas.openxmlformats.org/drawingml/2006/main">
+            <a:r>
+              <a:t>（切回PPT，停在本页）</a:t>
+            </a:r>
+          </a:p>
+          <a:p xmlns:a="http://schemas.openxmlformats.org/drawingml/2006/main"/>
+          <a:p xmlns:a="http://schemas.openxmlformats.org/drawingml/2006/main">
+            <a:r>
+              <a:t>硬指标：严重错误 5→0，必要步骤覆盖 90%→100%，证据覆盖 90%→100%。</a:t>
+            </a:r>
+          </a:p>
+          <a:p xmlns:a="http://schemas.openxmlformats.org/drawingml/2006/main"/>
+          <a:p xmlns:a="http://schemas.openxmlformats.org/drawingml/2006/main">
+            <a:r>
+              <a:t>更有意思的是多源消融：只给手册，覆盖80%；只给口述，90%；两者联合，才到100%。没有任何单一来源能替代老师傅的完整经验。</a:t>
+            </a:r>
+          </a:p>
+          <a:p xmlns:a="http://schemas.openxmlformats.org/drawingml/2006/main"/>
+          <a:p xmlns:a="http://schemas.openxmlformats.org/drawingml/2006/main">
+            <a:r>
+              <a:t>可复现性：DGX 直接跑和 Web 现场重算，各20次，共40轮，全部成功，语义指纹始终一致。不是"跑一次碰巧对了"，是"跑40次都一样"。</a:t>
+            </a:r>
+          </a:p>
+          <a:p xmlns:a="http://schemas.openxmlformats.org/drawingml/2006/main"/>
+          <a:p xmlns:a="http://schemas.openxmlformats.org/drawingml/2006/main">
+            <a:r>
+              <a:t>同一份 Gold 还生成了13步 SOP、13项清单、5题测验、海报和80秒视频。</a:t>
+            </a:r>
+          </a:p>
+          <a:p xmlns:a="http://schemas.openxmlformats.org/drawingml/2006/main"/>
+          <a:p xmlns:a="http://schemas.openxmlformats.org/drawingml/2006/main">
+            <a:r>
+              <a:t>【操作】强调前后指标对比，然后切到第8页。</a:t>
+            </a:r>
+          </a:p>
         </p:txBody>
       </p:sp>
       <p:sp>
@@ -1028,7 +1210,53 @@
         <p:txBody>
           <a:bodyPr xmlns:a="http://schemas.openxmlformats.org/drawingml/2006/main"/>
           <a:lstStyle xmlns:a="http://schemas.openxmlformats.org/drawingml/2006/main"/>
+          <a:p xmlns:a="http://schemas.openxmlformats.org/drawingml/2006/main">
+            <a:r>
+              <a:t>【第7段 · 160-180秒 · 本页停留约20秒，收尾】</a:t>
+            </a:r>
+          </a:p>
           <a:p xmlns:a="http://schemas.openxmlformats.org/drawingml/2006/main"/>
+          <a:p xmlns:a="http://schemas.openxmlformats.org/drawingml/2006/main">
+            <a:r>
+              <a:t>SkillForge 不是为 N31 写死的一份教程。</a:t>
+            </a:r>
+          </a:p>
+          <a:p xmlns:a="http://schemas.openxmlformats.org/drawingml/2006/main"/>
+          <a:p xmlns:a="http://schemas.openxmlformats.org/drawingml/2006/main">
+            <a:r>
+              <a:t>它是一条可迁移的 Agent 闭环：换一台设备、换一个行业，只要给它视频、手册和口述，它就能生成能回源、能质检、会局部自修订的培训包。</a:t>
+            </a:r>
+          </a:p>
+          <a:p xmlns:a="http://schemas.openxmlformats.org/drawingml/2006/main"/>
+          <a:p xmlns:a="http://schemas.openxmlformats.org/drawingml/2006/main">
+            <a:r>
+              <a:t>三个"可"：每一步可回源，每个问题可复检，每次修改可审计。</a:t>
+            </a:r>
+          </a:p>
+          <a:p xmlns:a="http://schemas.openxmlformats.org/drawingml/2006/main"/>
+          <a:p xmlns:a="http://schemas.openxmlformats.org/drawingml/2006/main">
+            <a:r>
+              <a:t>DGX Spark 让敏感视频留在现场，不上云、不出门。让专家经验真正成为可部署、可验证的组织能力。</a:t>
+            </a:r>
+          </a:p>
+          <a:p xmlns:a="http://schemas.openxmlformats.org/drawingml/2006/main"/>
+          <a:p xmlns:a="http://schemas.openxmlformats.org/drawingml/2006/main">
+            <a:r>
+              <a:t>我们不是生成更多内容，而是让内容能被相信。</a:t>
+            </a:r>
+          </a:p>
+          <a:p xmlns:a="http://schemas.openxmlformats.org/drawingml/2006/main"/>
+          <a:p xmlns:a="http://schemas.openxmlformats.org/drawingml/2006/main">
+            <a:r>
+              <a:t>谢谢大家。</a:t>
+            </a:r>
+          </a:p>
+          <a:p xmlns:a="http://schemas.openxmlformats.org/drawingml/2006/main"/>
+          <a:p xmlns:a="http://schemas.openxmlformats.org/drawingml/2006/main">
+            <a:r>
+              <a:t>【操作】展示结尾页，停在核心主张，微笑，等掌声。</a:t>
+            </a:r>
+          </a:p>
         </p:txBody>
       </p:sp>
       <p:sp>

</xml_diff>

<commit_message>
feat: rewrite speaker notes - conversational tone, no Docker, all 8 slides in order
- All 8 PPT slides shown sequentially, Web demo embedded between slide 3 and 4
- Removed all Docker mentions
- Language fully colloquial and audience-friendly
- Added humor and relatable analogies
</commit_message>
<xml_diff>
--- a/output/presentation/星星之火_SkillForge_三分钟路演_v2.pptx
+++ b/output/presentation/星星之火_SkillForge_三分钟路演_v2.pptx
@@ -544,31 +544,31 @@
           <a:lstStyle xmlns:a="http://schemas.openxmlformats.org/drawingml/2006/main"/>
           <a:p xmlns:a="http://schemas.openxmlformats.org/drawingml/2006/main">
             <a:r>
-              <a:t>【第1段 · 开场 · 0-20秒 · 本页停留约10秒】</a:t>
+              <a:t>【0–10秒 · 封面】</a:t>
             </a:r>
           </a:p>
           <a:p xmlns:a="http://schemas.openxmlformats.org/drawingml/2006/main"/>
           <a:p xmlns:a="http://schemas.openxmlformats.org/drawingml/2006/main">
             <a:r>
-              <a:t>大家好，我们是星星之火。今天带来的作品叫 SkillForge——匠传。</a:t>
+              <a:t>大家好，我们是星星之火。</a:t>
             </a:r>
           </a:p>
           <a:p xmlns:a="http://schemas.openxmlformats.org/drawingml/2006/main"/>
           <a:p xmlns:a="http://schemas.openxmlformats.org/drawingml/2006/main">
             <a:r>
-              <a:t>我们想解决一个问题：关键操作经验散落在视频、手册和老师傅口述里，人员一流动，知识就失真。SkillForge 要做的，是让专家经验变成可追溯、可验证、会自我修订的培训能力。</a:t>
+              <a:t>今天给大家看的东西叫 SkillForge，中文名"匠传"——师傅的手艺，传下去，不走样。</a:t>
             </a:r>
           </a:p>
           <a:p xmlns:a="http://schemas.openxmlformats.org/drawingml/2006/main"/>
           <a:p xmlns:a="http://schemas.openxmlformats.org/drawingml/2006/main">
             <a:r>
-              <a:t>以汉印 N31 换纸为例——看似简单，新手却很容易漏掉导纸夹、介质学习和试印验收，而普通内容生成无法证明每句话从哪里来。</a:t>
+              <a:t>一句话说清楚我们在干嘛：老师傅的操作经验，散在视频里、手册里、嘴上说的里。人一走，经验就断了。我们做的事，就是把这些经验自动变成一套能追溯、能验证、改错了还会自己修的培训包。</a:t>
             </a:r>
           </a:p>
           <a:p xmlns:a="http://schemas.openxmlformats.org/drawingml/2006/main"/>
           <a:p xmlns:a="http://schemas.openxmlformats.org/drawingml/2006/main">
             <a:r>
-              <a:t>【操作】展示封面，然后切到第2页。不操作网页。</a:t>
+              <a:t>【操作】展示封面，自然翻到第2页。</a:t>
             </a:r>
           </a:p>
         </p:txBody>
@@ -638,41 +638,35 @@
           <a:lstStyle xmlns:a="http://schemas.openxmlformats.org/drawingml/2006/main"/>
           <a:p xmlns:a="http://schemas.openxmlformats.org/drawingml/2006/main">
             <a:r>
-              <a:t>【第1段续 + 第2段 · 20-40秒 · 本页停留约15秒】</a:t>
+              <a:t>【10–30秒 · 痛点与输入】</a:t>
             </a:r>
           </a:p>
           <a:p xmlns:a="http://schemas.openxmlformats.org/drawingml/2006/main"/>
           <a:p xmlns:a="http://schemas.openxmlformats.org/drawingml/2006/main">
             <a:r>
-              <a:t>（指向左侧"最容易漏掉的不是大动作"）</a:t>
-            </a:r>
-          </a:p>
-          <a:p xmlns:a="http://schemas.openxmlformats.org/drawingml/2006/main">
-            <a:r>
-              <a:t>导纸夹宽度与居中、缝标介质学习、试印与完成验收——这三步，老师傅觉得"不用说"，新手觉得"不用学"，直到打印出来全是歪的。</a:t>
+              <a:t>（指左边）</a:t>
+            </a:r>
+          </a:p>
+          <a:p xmlns:a="http://schemas.openxmlformats.org/drawingml/2006/main">
+            <a:r>
+              <a:t>拿换打印纸这事来说——听起来谁不会啊？但新手真上手，导纸夹没调好、介质学习没做、试印没验收，打出来一沓全是歪的。老师傅觉得"这还用说？"新手觉得"这还用学？"——问题就出在这儿。</a:t>
             </a:r>
           </a:p>
           <a:p xmlns:a="http://schemas.openxmlformats.org/drawingml/2006/main"/>
           <a:p xmlns:a="http://schemas.openxmlformats.org/drawingml/2006/main">
             <a:r>
-              <a:t>（指向右侧三类输入）</a:t>
-            </a:r>
-          </a:p>
-          <a:p xmlns:a="http://schemas.openxmlformats.org/drawingml/2006/main">
-            <a:r>
-              <a:t>SkillForge 接收三种原料：专家操作视频，绑定时间点；设备 PDF 手册，绑定页码；专家口述录音，绑定时间段。原始敏感素材留在本地，公开演示只用安全派生物。</a:t>
+              <a:t>（指右边）</a:t>
+            </a:r>
+          </a:p>
+          <a:p xmlns:a="http://schemas.openxmlformats.org/drawingml/2006/main">
+            <a:r>
+              <a:t>我们喂给系统三样东西：师傅的操作视频，精确到第几秒；设备手册 PDF，精确到第几页；师傅口述录音，精确到哪个时间段。一共6段视频、2份手册、12段口述，提炼出154条证据——后面生成的每一句话，都能追到是哪个视频第几秒、哪本手册第几页说的。</a:t>
             </a:r>
           </a:p>
           <a:p xmlns:a="http://schemas.openxmlformats.org/drawingml/2006/main"/>
           <a:p xmlns:a="http://schemas.openxmlformats.org/drawingml/2006/main">
             <a:r>
-              <a:t>6段自摄视频、2份手册、12段口述，汇成154条 Evidence Catalog——每句话都有出处。</a:t>
-            </a:r>
-          </a:p>
-          <a:p xmlns:a="http://schemas.openxmlformats.org/drawingml/2006/main"/>
-          <a:p xmlns:a="http://schemas.openxmlformats.org/drawingml/2006/main">
-            <a:r>
-              <a:t>【操作】展示三类输入区域，然后切到第3页。</a:t>
+              <a:t>【操作】翻到第3页。</a:t>
             </a:r>
           </a:p>
         </p:txBody>
@@ -742,25 +736,57 @@
           <a:lstStyle xmlns:a="http://schemas.openxmlformats.org/drawingml/2006/main"/>
           <a:p xmlns:a="http://schemas.openxmlformats.org/drawingml/2006/main">
             <a:r>
-              <a:t>【第2段续 · 本页停留约5秒，快速过渡】</a:t>
+              <a:t>【30–40秒 · 五个Agent】</a:t>
             </a:r>
           </a:p>
           <a:p xmlns:a="http://schemas.openxmlformats.org/drawingml/2006/main"/>
           <a:p xmlns:a="http://schemas.openxmlformats.org/drawingml/2006/main">
             <a:r>
-              <a:t>五个 Agent，各司其职：Perception 提取证据，SOP 规划步骤，Creator 生成内容，Verifier 质检找茬，Revision 只改出错的地方。</a:t>
+              <a:t>系统里有五个"工人"，各管一摊：</a:t>
             </a:r>
           </a:p>
           <a:p xmlns:a="http://schemas.openxmlformats.org/drawingml/2006/main"/>
           <a:p xmlns:a="http://schemas.openxmlformats.org/drawingml/2006/main">
             <a:r>
-              <a:t>注意这个闭环——Verifier 发现问题不是推倒重来，而是精准外科手术：哪里错了改哪里，其余不动。</a:t>
+              <a:t>第一个负责"看"——从视频、手册、录音里提取证据；</a:t>
+            </a:r>
+          </a:p>
+          <a:p xmlns:a="http://schemas.openxmlformats.org/drawingml/2006/main">
+            <a:r>
+              <a:t>第二个负责"想"——规划操作步骤和先后顺序；</a:t>
+            </a:r>
+          </a:p>
+          <a:p xmlns:a="http://schemas.openxmlformats.org/drawingml/2006/main">
+            <a:r>
+              <a:t>第三个负责"写"——生成SOP、清单、测验这些培训内容；</a:t>
+            </a:r>
+          </a:p>
+          <a:p xmlns:a="http://schemas.openxmlformats.org/drawingml/2006/main">
+            <a:r>
+              <a:t>第四个负责"查"——拿着规则逐条质检，找出哪里写错了、哪里没依据；</a:t>
+            </a:r>
+          </a:p>
+          <a:p xmlns:a="http://schemas.openxmlformats.org/drawingml/2006/main">
+            <a:r>
+              <a:t>第五个负责"改"——只改出错的那几处，其余一个字不动。</a:t>
             </a:r>
           </a:p>
           <a:p xmlns:a="http://schemas.openxmlformats.org/drawingml/2006/main"/>
           <a:p xmlns:a="http://schemas.openxmlformats.org/drawingml/2006/main">
             <a:r>
-              <a:t>【操作】快速展示后切到浏览器（Web）。Alt+Tab 切换。</a:t>
+              <a:t>关键是：查出来不是推倒重来，是精准修改。就像改作文，不是把整篇撕了重写，是只改病句。</a:t>
+            </a:r>
+          </a:p>
+          <a:p xmlns:a="http://schemas.openxmlformats.org/drawingml/2006/main"/>
+          <a:p xmlns:a="http://schemas.openxmlformats.org/drawingml/2006/main">
+            <a:r>
+              <a:t>好，接下来我们直接在网页上跑一遍给大家看。</a:t>
+            </a:r>
+          </a:p>
+          <a:p xmlns:a="http://schemas.openxmlformats.org/drawingml/2006/main"/>
+          <a:p xmlns:a="http://schemas.openxmlformats.org/drawingml/2006/main">
+            <a:r>
+              <a:t>【操作】Alt+Tab 切到浏览器（Web 已提前打开在 http://127.0.0.1:17860）。</a:t>
             </a:r>
           </a:p>
         </p:txBody>
@@ -830,31 +856,37 @@
           <a:lstStyle xmlns:a="http://schemas.openxmlformats.org/drawingml/2006/main"/>
           <a:p xmlns:a="http://schemas.openxmlformats.org/drawingml/2006/main">
             <a:r>
-              <a:t>【第4段兜底 · 70-110秒 · 仅当Web不可用时展示本页】</a:t>
+              <a:t>【约105–120秒 · 质检与修订总结】</a:t>
             </a:r>
           </a:p>
           <a:p xmlns:a="http://schemas.openxmlformats.org/drawingml/2006/main"/>
           <a:p xmlns:a="http://schemas.openxmlformats.org/drawingml/2006/main">
             <a:r>
-              <a:t>如果 Web 演示挂了，用这页兜底：</a:t>
+              <a:t>（从Web切回PPT后展示本页）</a:t>
             </a:r>
           </a:p>
           <a:p xmlns:a="http://schemas.openxmlformats.org/drawingml/2006/main"/>
           <a:p xmlns:a="http://schemas.openxmlformats.org/drawingml/2006/main">
             <a:r>
-              <a:t>Verifier 在 Gold 受控错误集上发现5个严重问题：缺步骤、顺序错误、无依据工具、无依据参数。它引用视频 E039、手册 E104 P20、口述 E148 等多源证据，执行4处局部修订，复检后严重错误归零。</a:t>
+              <a:t>刚才大家看到的就是这个过程的总结：</a:t>
             </a:r>
           </a:p>
           <a:p xmlns:a="http://schemas.openxmlformats.org/drawingml/2006/main"/>
           <a:p xmlns:a="http://schemas.openxmlformats.org/drawingml/2006/main">
             <a:r>
-              <a:t>关键数字：5→0，4处修改，不整包重写。</a:t>
+              <a:t>系统发现了5个严重问题——少了一步、顺序反了、有两个操作没有手册或视频依据。然后它引用证据，做了4处修改，再查一遍，严重问题归零。</a:t>
             </a:r>
           </a:p>
           <a:p xmlns:a="http://schemas.openxmlformats.org/drawingml/2006/main"/>
           <a:p xmlns:a="http://schemas.openxmlformats.org/drawingml/2006/main">
             <a:r>
-              <a:t>（正常情况下这页不展示，直接在 Web 上操作。）</a:t>
+              <a:t>注意：只改了4个地方，其他内容原封不动。不是"AI觉得不好，全部重写"，是"哪里有问题改哪里"。</a:t>
+            </a:r>
+          </a:p>
+          <a:p xmlns:a="http://schemas.openxmlformats.org/drawingml/2006/main"/>
+          <a:p xmlns:a="http://schemas.openxmlformats.org/drawingml/2006/main">
+            <a:r>
+              <a:t>【操作】短暂停留，翻到第5页。</a:t>
             </a:r>
           </a:p>
         </p:txBody>
@@ -924,25 +956,31 @@
           <a:lstStyle xmlns:a="http://schemas.openxmlformats.org/drawingml/2006/main"/>
           <a:p xmlns:a="http://schemas.openxmlformats.org/drawingml/2006/main">
             <a:r>
-              <a:t>【第3-4段辅助 · 可选展示】</a:t>
+              <a:t>【约120–130秒 · 每一步都能追到源头】</a:t>
             </a:r>
           </a:p>
           <a:p xmlns:a="http://schemas.openxmlformats.org/drawingml/2006/main"/>
           <a:p xmlns:a="http://schemas.openxmlformats.org/drawingml/2006/main">
             <a:r>
-              <a:t>以 S09 缝标学习为例：一条步骤同时引用 PDF 第20页、视频 190-195秒、口述 153-195秒。</a:t>
+              <a:t>这页展示的是"追溯"到底长什么样。</a:t>
             </a:r>
           </a:p>
           <a:p xmlns:a="http://schemas.openxmlformats.org/drawingml/2006/main"/>
           <a:p xmlns:a="http://schemas.openxmlformats.org/drawingml/2006/main">
             <a:r>
-              <a:t>引用存在不等于证据充分——低可见度、遮挡和来源冲突会进入待复核，不会被伪装成事实。这是 SkillForge 和"AI 生成教程"的本质区别：我们不只给引用，还给置信度边界。</a:t>
+              <a:t>比如第9步"缝标学习"，它同时引用了三个来源：手册第20页、操作视频第190到195秒、师傅口述的第153到195秒。三个来源互相印证，这一步才算"有据可查"。</a:t>
             </a:r>
           </a:p>
           <a:p xmlns:a="http://schemas.openxmlformats.org/drawingml/2006/main"/>
           <a:p xmlns:a="http://schemas.openxmlformats.org/drawingml/2006/main">
             <a:r>
-              <a:t>（正常流程中这页不单独展示，Web 上直接点 Evidence ID 看。）</a:t>
+              <a:t>而且我们不会硬撑——如果视频拍得不清楚、有遮挡，系统会标记"待复核"，不会假装自己看清楚了。这是跟普通AI生成最大的区别：我们不只给答案，还告诉你"这个答案有多靠谱"。</a:t>
+            </a:r>
+          </a:p>
+          <a:p xmlns:a="http://schemas.openxmlformats.org/drawingml/2006/main"/>
+          <a:p xmlns:a="http://schemas.openxmlformats.org/drawingml/2006/main">
+            <a:r>
+              <a:t>【操作】翻到第6页。</a:t>
             </a:r>
           </a:p>
         </p:txBody>
@@ -1012,31 +1050,31 @@
           <a:lstStyle xmlns:a="http://schemas.openxmlformats.org/drawingml/2006/main"/>
           <a:p xmlns:a="http://schemas.openxmlformats.org/drawingml/2006/main">
             <a:r>
-              <a:t>【第3段兜底 · 40-70秒 · 仅当Web不可用时展示本页】</a:t>
+              <a:t>【约130–140秒 · DGX Spark 本地计算】</a:t>
             </a:r>
           </a:p>
           <a:p xmlns:a="http://schemas.openxmlformats.org/drawingml/2006/main"/>
           <a:p xmlns:a="http://schemas.openxmlformats.org/drawingml/2006/main">
             <a:r>
-              <a:t>如果 Web 没起来，用这页讲 DGX：</a:t>
+              <a:t>视频处理是在这台 NVIDIA DGX Spark 上跑的。6段视频、420帧画面、筛出50个关键帧，端到端13秒。</a:t>
             </a:r>
           </a:p>
           <a:p xmlns:a="http://schemas.openxmlformats.org/drawingml/2006/main"/>
           <a:p xmlns:a="http://schemas.openxmlformats.org/drawingml/2006/main">
             <a:r>
-              <a:t>NVIDIA GB10 上跑原生 CUDA，6段安全视频、420帧处理、50个候选帧，端到端13秒。</a:t>
+              <a:t>但要说清楚一件事：GPU 只负责"哪些画面值得看"，真正"看懂了什么"是 Agent 结合手册和口述来判断的。机器筛选是候选，不是结论。</a:t>
             </a:r>
           </a:p>
           <a:p xmlns:a="http://schemas.openxmlformats.org/drawingml/2006/main"/>
           <a:p xmlns:a="http://schemas.openxmlformats.org/drawingml/2006/main">
             <a:r>
-              <a:t>重点：候选筛选不等于语义结论。GPU 负责"哪些帧值得看"，Agent 负责"看到了什么"。P0 全程不需要 Docker，原生 Python 加 FFmpeg 就能跑。</a:t>
+              <a:t>而且所有视频都留在这台机器上，不上传、不出门。对工厂、医院这些场景来说，这点很重要。</a:t>
             </a:r>
           </a:p>
           <a:p xmlns:a="http://schemas.openxmlformats.org/drawingml/2006/main"/>
           <a:p xmlns:a="http://schemas.openxmlformats.org/drawingml/2006/main">
             <a:r>
-              <a:t>（正常情况下这页不展示，直接在 Web 上指向 DGX 区域。）</a:t>
+              <a:t>【操作】翻到第7页。</a:t>
             </a:r>
           </a:p>
         </p:txBody>
@@ -1106,43 +1144,53 @@
           <a:lstStyle xmlns:a="http://schemas.openxmlformats.org/drawingml/2006/main"/>
           <a:p xmlns:a="http://schemas.openxmlformats.org/drawingml/2006/main">
             <a:r>
-              <a:t>【第6段 · 140-160秒 · 本页停留约20秒】</a:t>
+              <a:t>【约140–160秒 · 硬指标】</a:t>
             </a:r>
           </a:p>
           <a:p xmlns:a="http://schemas.openxmlformats.org/drawingml/2006/main"/>
           <a:p xmlns:a="http://schemas.openxmlformats.org/drawingml/2006/main">
             <a:r>
-              <a:t>（切回PPT，停在本页）</a:t>
+              <a:t>说数字：</a:t>
             </a:r>
           </a:p>
           <a:p xmlns:a="http://schemas.openxmlformats.org/drawingml/2006/main"/>
           <a:p xmlns:a="http://schemas.openxmlformats.org/drawingml/2006/main">
             <a:r>
-              <a:t>硬指标：严重错误 5→0，必要步骤覆盖 90%→100%，证据覆盖 90%→100%。</a:t>
+              <a:t>严重问题，从5个降到0。</a:t>
+            </a:r>
+          </a:p>
+          <a:p xmlns:a="http://schemas.openxmlformats.org/drawingml/2006/main">
+            <a:r>
+              <a:t>必要步骤覆盖率，从90%升到100%。</a:t>
+            </a:r>
+          </a:p>
+          <a:p xmlns:a="http://schemas.openxmlformats.org/drawingml/2006/main">
+            <a:r>
+              <a:t>证据覆盖率，从90%升到100%。</a:t>
             </a:r>
           </a:p>
           <a:p xmlns:a="http://schemas.openxmlformats.org/drawingml/2006/main"/>
           <a:p xmlns:a="http://schemas.openxmlformats.org/drawingml/2006/main">
             <a:r>
-              <a:t>更有意思的是多源消融：只给手册，覆盖80%；只给口述，90%；两者联合，才到100%。没有任何单一来源能替代老师傅的完整经验。</a:t>
+              <a:t>有个有意思的发现：只给手册，覆盖80%；只给师傅口述，覆盖90%；两样合在一起，才到100%。说明老师傅嘴上那些"顺便说一句"，真的是手册里写不到的。</a:t>
             </a:r>
           </a:p>
           <a:p xmlns:a="http://schemas.openxmlformats.org/drawingml/2006/main"/>
           <a:p xmlns:a="http://schemas.openxmlformats.org/drawingml/2006/main">
             <a:r>
-              <a:t>可复现性：DGX 直接跑和 Web 现场重算，各20次，共40轮，全部成功，语义指纹始终一致。不是"跑一次碰巧对了"，是"跑40次都一样"。</a:t>
+              <a:t>可复现性：同一套流程跑了40次，每次结果一模一样。不是碰巧对了，是稳定可复现。</a:t>
             </a:r>
           </a:p>
           <a:p xmlns:a="http://schemas.openxmlformats.org/drawingml/2006/main"/>
           <a:p xmlns:a="http://schemas.openxmlformats.org/drawingml/2006/main">
             <a:r>
-              <a:t>同一份 Gold 还生成了13步 SOP、13项清单、5题测验、海报和80秒视频。</a:t>
+              <a:t>同一份数据还自动生成了13步SOP、13项手机检查清单、5道测验题、一张A4海报和一段80秒培训视频。</a:t>
             </a:r>
           </a:p>
           <a:p xmlns:a="http://schemas.openxmlformats.org/drawingml/2006/main"/>
           <a:p xmlns:a="http://schemas.openxmlformats.org/drawingml/2006/main">
             <a:r>
-              <a:t>【操作】强调前后指标对比，然后切到第8页。</a:t>
+              <a:t>【操作】翻到第8页。</a:t>
             </a:r>
           </a:p>
         </p:txBody>
@@ -1212,49 +1260,43 @@
           <a:lstStyle xmlns:a="http://schemas.openxmlformats.org/drawingml/2006/main"/>
           <a:p xmlns:a="http://schemas.openxmlformats.org/drawingml/2006/main">
             <a:r>
-              <a:t>【第7段 · 160-180秒 · 本页停留约20秒，收尾】</a:t>
+              <a:t>【约160–180秒 · 收尾】</a:t>
             </a:r>
           </a:p>
           <a:p xmlns:a="http://schemas.openxmlformats.org/drawingml/2006/main"/>
           <a:p xmlns:a="http://schemas.openxmlformats.org/drawingml/2006/main">
             <a:r>
-              <a:t>SkillForge 不是为 N31 写死的一份教程。</a:t>
+              <a:t>最后说一句：SkillForge 不是给 N31 打印机写的一份教程。</a:t>
             </a:r>
           </a:p>
           <a:p xmlns:a="http://schemas.openxmlformats.org/drawingml/2006/main"/>
           <a:p xmlns:a="http://schemas.openxmlformats.org/drawingml/2006/main">
             <a:r>
-              <a:t>它是一条可迁移的 Agent 闭环：换一台设备、换一个行业，只要给它视频、手册和口述，它就能生成能回源、能质检、会局部自修订的培训包。</a:t>
+              <a:t>它是一条通用的流水线——换一台设备、换一个行业，只要给它操作视频、手册和师傅口述，它就能生成一套能追源头、能查问题、能自己改错的培训包。</a:t>
             </a:r>
           </a:p>
           <a:p xmlns:a="http://schemas.openxmlformats.org/drawingml/2006/main"/>
           <a:p xmlns:a="http://schemas.openxmlformats.org/drawingml/2006/main">
             <a:r>
-              <a:t>三个"可"：每一步可回源，每个问题可复检，每次修改可审计。</a:t>
+              <a:t>三句话总结：每一步能追到出处，每个问题能复查，每次修改有记录。</a:t>
             </a:r>
           </a:p>
           <a:p xmlns:a="http://schemas.openxmlformats.org/drawingml/2006/main"/>
           <a:p xmlns:a="http://schemas.openxmlformats.org/drawingml/2006/main">
             <a:r>
-              <a:t>DGX Spark 让敏感视频留在现场，不上云、不出门。让专家经验真正成为可部署、可验证的组织能力。</a:t>
+              <a:t>我们不是生成更多内容，而是让内容能被相信。</a:t>
             </a:r>
           </a:p>
           <a:p xmlns:a="http://schemas.openxmlformats.org/drawingml/2006/main"/>
           <a:p xmlns:a="http://schemas.openxmlformats.org/drawingml/2006/main">
             <a:r>
-              <a:t>我们不是生成更多内容，而是让内容能被相信。</a:t>
+              <a:t>谢谢大家。</a:t>
             </a:r>
           </a:p>
           <a:p xmlns:a="http://schemas.openxmlformats.org/drawingml/2006/main"/>
           <a:p xmlns:a="http://schemas.openxmlformats.org/drawingml/2006/main">
             <a:r>
-              <a:t>谢谢大家。</a:t>
-            </a:r>
-          </a:p>
-          <a:p xmlns:a="http://schemas.openxmlformats.org/drawingml/2006/main"/>
-          <a:p xmlns:a="http://schemas.openxmlformats.org/drawingml/2006/main">
-            <a:r>
-              <a:t>【操作】展示结尾页，停在核心主张，微笑，等掌声。</a:t>
+              <a:t>【操作】停在结尾页，微笑，等掌声。</a:t>
             </a:r>
           </a:p>
         </p:txBody>

</xml_diff>